<commit_message>
Add the Esri basemap to Fig 1, fix a caption clip, and add paper figures
Fig 1 now sits on Esri Light Gray Canvas tiles warped into EPSG:5070, which is
the basemap Ed asked for. Tiles are cached as a GeoTIFF so rebuilds need no
network. The previous base drew Lake Michigan and Lake Superior as land, since
TIGER county polygons extend into them.

fit_height defaulted to the regular face while the figure captions render bold,
so Fig 2's caption was measured as one line and rendered as two, spilling past
the template's content bottom. Fixed, and Fig 2's plot height reduced to 3.20 in
so the corrected box fits.

Poster text: Ed's NCAR funding wording added verbatim alongside the ASSIP line,
Alice Fox added as an author, basemap credited in Major Citations.

make_paper_figures.py produces five publication figures at 300 dpi in PNG and
vector PDF. Palette checked with a colour-vision validator.

The manuscript draft itself stays out of the repo.
</commit_message>
<xml_diff>
--- a/figures/Oughton_Avilash_Angirekula_2026ASSIP_Poster.pptx
+++ b/figures/Oughton_Avilash_Angirekula_2026ASSIP_Poster.pptx
@@ -5512,7 +5512,7 @@
                 </a:solidFill>
                 <a:latin typeface="Arial"/>
               </a:rPr>
-              <a:t>Avilash Angirekula¹, Dennies Bor¹, Edward J. Oughton¹</a:t>
+              <a:t>Avilash Angirekula¹, Dennies Bor¹, Alice Fox¹, Edward J. Oughton¹</a:t>
             </a:r>
             <a:endParaRPr sz="3600" baseline="30000" dirty="0">
               <a:solidFill>
@@ -6310,7 +6310,7 @@
         <p:spPr>
           <a:xfrm>
             <a:off x="22090621" y="16218476"/>
-            <a:ext cx="10418660" cy="3646932"/>
+            <a:ext cx="10418660" cy="4036821"/>
           </a:xfrm>
           <a:prstGeom prst="rect">
             <a:avLst/>
@@ -6449,6 +6449,25 @@
               <a:t>WRI (2023) Aqueduct 4.0 Water Risk Atlas.</a:t>
             </a:r>
           </a:p>
+          <a:p>
+            <a:pPr algn="l">
+              <a:lnSpc>
+                <a:spcPct val="90000"/>
+              </a:lnSpc>
+              <a:spcAft>
+                <a:spcPts val="1000"/>
+              </a:spcAft>
+            </a:pPr>
+            <a:r>
+              <a:rPr sz="2000" b="0">
+                <a:solidFill>
+                  <a:srgbClr val="333333"/>
+                </a:solidFill>
+                <a:latin typeface="Arial"/>
+              </a:rPr>
+              <a:t>Fig 1 basemap: Esri Light Gray Canvas. Tiles © Esri, DeLorme, NAVTEQ.</a:t>
+            </a:r>
+          </a:p>
         </p:txBody>
       </p:sp>
       <p:sp>
@@ -6466,7 +6485,7 @@
         <p:spPr>
           <a:xfrm>
             <a:off x="22061036" y="21636297"/>
-            <a:ext cx="10480664" cy="1215517"/>
+            <a:ext cx="10480664" cy="2175002"/>
           </a:xfrm>
           <a:prstGeom prst="rect">
             <a:avLst/>
@@ -6501,7 +6520,7 @@
                 </a:solidFill>
                 <a:latin typeface="Arial"/>
               </a:rPr>
-              <a:t>This research was made possible through the support of George Mason University's College of Science, which supports the ASSIP Program, and by the NCAR multi-hazards project.</a:t>
+              <a:t>This research was made possible through the support of George Mason University's College of Science, which supports the ASSIP Program.</a:t>
             </a:r>
             <a:endParaRPr sz="2600" i="1" dirty="0">
               <a:latin typeface="Arial" panose="020B0604020202020204" pitchFamily="34" charset="0"/>
@@ -6509,6 +6528,25 @@
               <a:cs typeface="Arial" panose="020B0604020202020204" pitchFamily="34" charset="0"/>
               <a:sym typeface="Palatino"/>
             </a:endParaRPr>
+          </a:p>
+          <a:p>
+            <a:pPr algn="l">
+              <a:lnSpc>
+                <a:spcPct val="95000"/>
+              </a:lnSpc>
+              <a:spcAft>
+                <a:spcPts val="1000"/>
+              </a:spcAft>
+            </a:pPr>
+            <a:r>
+              <a:rPr sz="2000" b="0">
+                <a:solidFill>
+                  <a:srgbClr val="333333"/>
+                </a:solidFill>
+                <a:latin typeface="Arial"/>
+              </a:rPr>
+              <a:t>DB and EO were supported by the National Science Foundation National Center for Atmospheric Research (NCAR) Innovator Supplemental Funding grant entitled “A Multi-Hazard, Multi-Infrastructure Vulnerability Assessment for the Continental United States (CONUS)”</a:t>
+            </a:r>
           </a:p>
         </p:txBody>
       </p:sp>
@@ -7795,7 +7833,7 @@
         <p:spPr>
           <a:xfrm>
             <a:off x="10965973" y="8634133"/>
-            <a:ext cx="10781748" cy="4932334"/>
+            <a:ext cx="10781748" cy="4881235"/>
           </a:xfrm>
           <a:prstGeom prst="rect">
             <a:avLst/>
@@ -7810,7 +7848,7 @@
         </p:nvSpPr>
         <p:spPr>
           <a:xfrm>
-            <a:off x="10965973" y="13639618"/>
+            <a:off x="10965973" y="13588520"/>
             <a:ext cx="10781748" cy="1298765"/>
           </a:xfrm>
           <a:prstGeom prst="rect">
@@ -7852,7 +7890,7 @@
         </p:nvSpPr>
         <p:spPr>
           <a:xfrm>
-            <a:off x="10965973" y="15029824"/>
+            <a:off x="10965973" y="14978726"/>
             <a:ext cx="10781748" cy="4965953"/>
           </a:xfrm>
           <a:prstGeom prst="rect">
@@ -7940,8 +7978,8 @@
         </p:blipFill>
         <p:spPr>
           <a:xfrm>
-            <a:off x="10965973" y="20087218"/>
-            <a:ext cx="10781748" cy="3372490"/>
+            <a:off x="10965973" y="20036120"/>
+            <a:ext cx="10781748" cy="3181543"/>
           </a:xfrm>
           <a:prstGeom prst="rect">
             <a:avLst/>
@@ -7956,8 +7994,8 @@
         </p:nvSpPr>
         <p:spPr>
           <a:xfrm>
-            <a:off x="10965973" y="23514572"/>
-            <a:ext cx="10781748" cy="688276"/>
+            <a:off x="10965973" y="23272527"/>
+            <a:ext cx="10781748" cy="993521"/>
           </a:xfrm>
           <a:prstGeom prst="rect">
             <a:avLst/>

</xml_diff>